<commit_message>
Fix slide 22, 23, 24
* Add NVIDIA explicitly for cluster level
* Use generic subgroup term
* Add model qualifier & advice to query device for model/vendor-specific limits
</commit_message>
<xml_diff>
--- a/gpu_programming.pptx
+++ b/gpu_programming.pptx
@@ -16892,6 +16892,54 @@
           </a:p>
         </p:txBody>
       </p:sp>
+      <p:sp>
+        <p:nvSpPr>
+          <p:cNvPr id="7" name="TextBox 6">
+            <a:extLst>
+              <a:ext uri="{FF2B5EF4-FFF2-40B4-BE49-F238E27FC236}">
+                <a16:creationId xmlns:a16="http://schemas.microsoft.com/office/drawing/2014/main" id="{2614896B-B657-57EC-27A1-95D7A4CB5E62}"/>
+              </a:ext>
+            </a:extLst>
+          </p:cNvPr>
+          <p:cNvSpPr txBox="1"/>
+          <p:nvPr/>
+        </p:nvSpPr>
+        <p:spPr>
+          <a:xfrm>
+            <a:off x="4834099" y="5525353"/>
+            <a:ext cx="3721981" cy="830997"/>
+          </a:xfrm>
+          <a:prstGeom prst="rect">
+            <a:avLst/>
+          </a:prstGeom>
+          <a:noFill/>
+          <a:ln>
+            <a:solidFill>
+              <a:schemeClr val="tx1"/>
+            </a:solidFill>
+          </a:ln>
+        </p:spPr>
+        <p:txBody>
+          <a:bodyPr wrap="none" rtlCol="0">
+            <a:spAutoFit/>
+          </a:bodyPr>
+          <a:lstStyle/>
+          <a:p>
+            <a:r>
+              <a:rPr lang="en-US" sz="2400" dirty="0"/>
+              <a:t>Numbers for NVIDIA H100,</a:t>
+            </a:r>
+            <a:br>
+              <a:rPr lang="en-US" sz="2400" dirty="0"/>
+            </a:br>
+            <a:r>
+              <a:rPr lang="en-US" sz="2400" dirty="0"/>
+              <a:t>query the device!</a:t>
+            </a:r>
+            <a:endParaRPr lang="LID4096" sz="2400" dirty="0"/>
+          </a:p>
+        </p:txBody>
+      </p:sp>
     </p:spTree>
     <p:extLst>
       <p:ext uri="{BB962C8B-B14F-4D97-AF65-F5344CB8AC3E}">
@@ -17567,6 +17615,54 @@
               <a:t> latency hiding</a:t>
             </a:r>
             <a:endParaRPr lang="LID4096" sz="2800" dirty="0"/>
+          </a:p>
+        </p:txBody>
+      </p:sp>
+      <p:sp>
+        <p:nvSpPr>
+          <p:cNvPr id="7" name="TextBox 6">
+            <a:extLst>
+              <a:ext uri="{FF2B5EF4-FFF2-40B4-BE49-F238E27FC236}">
+                <a16:creationId xmlns:a16="http://schemas.microsoft.com/office/drawing/2014/main" id="{242471BA-612A-2249-05CC-EEA67CEED1CB}"/>
+              </a:ext>
+            </a:extLst>
+          </p:cNvPr>
+          <p:cNvSpPr txBox="1"/>
+          <p:nvPr/>
+        </p:nvSpPr>
+        <p:spPr>
+          <a:xfrm>
+            <a:off x="7842770" y="1870075"/>
+            <a:ext cx="3721981" cy="830997"/>
+          </a:xfrm>
+          <a:prstGeom prst="rect">
+            <a:avLst/>
+          </a:prstGeom>
+          <a:noFill/>
+          <a:ln>
+            <a:solidFill>
+              <a:schemeClr val="tx1"/>
+            </a:solidFill>
+          </a:ln>
+        </p:spPr>
+        <p:txBody>
+          <a:bodyPr wrap="none" rtlCol="0">
+            <a:spAutoFit/>
+          </a:bodyPr>
+          <a:lstStyle/>
+          <a:p>
+            <a:r>
+              <a:rPr lang="en-US" sz="2400" dirty="0"/>
+              <a:t>Numbers for NVIDIA H100,</a:t>
+            </a:r>
+            <a:br>
+              <a:rPr lang="en-US" sz="2400" dirty="0"/>
+            </a:br>
+            <a:r>
+              <a:rPr lang="en-US" sz="2400" dirty="0"/>
+              <a:t>query the device!</a:t>
+            </a:r>
+            <a:endParaRPr lang="LID4096" sz="2400" dirty="0"/>
           </a:p>
         </p:txBody>
       </p:sp>
@@ -18288,7 +18384,17 @@
             <a:pPr lvl="1"/>
             <a:r>
               <a:rPr lang="en-US" dirty="0"/>
-              <a:t>Warp: implicit lockstep</a:t>
+              <a:t>Subgroup: implicit lockstep execution </a:t>
+            </a:r>
+            <a:r>
+              <a:rPr lang="en-US" dirty="0">
+                <a:sym typeface="Symbol" panose="05050102010706020507" pitchFamily="18" charset="2"/>
+              </a:rPr>
+              <a:t></a:t>
+            </a:r>
+            <a:r>
+              <a:rPr lang="en-US" dirty="0"/>
+              <a:t> synchronization</a:t>
             </a:r>
           </a:p>
           <a:p>
@@ -18302,7 +18408,7 @@
             <a:pPr lvl="1"/>
             <a:r>
               <a:rPr lang="en-US" dirty="0"/>
-              <a:t>Cluster (H100+): cluster boundaries</a:t>
+              <a:t>Cluster (NVIDIA H100+): cluster boundaries</a:t>
             </a:r>
           </a:p>
           <a:p>

</xml_diff>

<commit_message>
Fix slides 16, 17, 31
* Fix unit ambiguity
* Fix aggregate ambiguity
</commit_message>
<xml_diff>
--- a/gpu_programming.pptx
+++ b/gpu_programming.pptx
@@ -5,7 +5,7 @@
     <p:sldMasterId id="2147483648" r:id="rId1"/>
   </p:sldMasterIdLst>
   <p:notesMasterIdLst>
-    <p:notesMasterId r:id="rId34"/>
+    <p:notesMasterId r:id="rId35"/>
   </p:notesMasterIdLst>
   <p:sldIdLst>
     <p:sldId id="257" r:id="rId2"/>
@@ -40,6 +40,7 @@
     <p:sldId id="370" r:id="rId31"/>
     <p:sldId id="377" r:id="rId32"/>
     <p:sldId id="371" r:id="rId33"/>
+    <p:sldId id="389" r:id="rId34"/>
   </p:sldIdLst>
   <p:sldSz cx="12192000" cy="6858000"/>
   <p:notesSz cx="6858000" cy="9144000"/>
@@ -10209,7 +10210,7 @@
             <a:pPr lvl="2"/>
             <a:r>
               <a:rPr lang="en-US" dirty="0"/>
-              <a:t>50 Gb/s/lane (bi-directional) </a:t>
+              <a:t>50 GB/s/lane (bi-directional) </a:t>
             </a:r>
             <a:r>
               <a:rPr lang="en-US" dirty="0">
@@ -10219,7 +10220,7 @@
             </a:r>
             <a:r>
               <a:rPr lang="en-US" dirty="0"/>
-              <a:t> 200 Gb/s between GPUs</a:t>
+              <a:t> 200 GB/s between GPUs (100 GB/s each way)</a:t>
             </a:r>
           </a:p>
           <a:p>
@@ -10230,6 +10231,10 @@
             </a:r>
           </a:p>
           <a:p>
+            <a:r>
+              <a:rPr lang="en-US" dirty="0"/>
+              <a:t>NVIDIA </a:t>
+            </a:r>
             <a:r>
               <a:rPr lang="en-US" dirty="0" err="1"/>
               <a:t>Infiniband</a:t>
@@ -10676,113 +10681,101 @@
             <p:ph idx="1"/>
           </p:nvPr>
         </p:nvSpPr>
-        <p:spPr/>
+        <p:spPr>
+          <a:xfrm>
+            <a:off x="838199" y="1825625"/>
+            <a:ext cx="4363874" cy="4351338"/>
+          </a:xfrm>
+        </p:spPr>
         <p:txBody>
           <a:bodyPr>
-            <a:normAutofit lnSpcReduction="10000"/>
+            <a:normAutofit/>
           </a:bodyPr>
           <a:lstStyle/>
           <a:p>
             <a:r>
-              <a:rPr lang="en-US" dirty="0"/>
+              <a:rPr lang="en-US" sz="2400" dirty="0"/>
               <a:t>Global GPU memory</a:t>
             </a:r>
             <a:br>
-              <a:rPr lang="en-US" dirty="0"/>
+              <a:rPr lang="en-US" sz="2400" dirty="0"/>
             </a:br>
             <a:r>
-              <a:rPr lang="en-US" dirty="0"/>
+              <a:rPr lang="en-US" sz="2400" dirty="0"/>
               <a:t>    </a:t>
             </a:r>
             <a:r>
-              <a:rPr lang="en-US" dirty="0">
+              <a:rPr lang="en-US" sz="2400" dirty="0">
                 <a:sym typeface="Symbol" panose="05050102010706020507" pitchFamily="18" charset="2"/>
               </a:rPr>
-              <a:t> 2 Tb/s</a:t>
-            </a:r>
-          </a:p>
-          <a:p>
-            <a:r>
-              <a:rPr lang="en-US" dirty="0" err="1">
+              <a:t> 2 TB/s</a:t>
+            </a:r>
+          </a:p>
+          <a:p>
+            <a:r>
+              <a:rPr lang="en-US" sz="2400" dirty="0" err="1">
                 <a:sym typeface="Symbol" panose="05050102010706020507" pitchFamily="18" charset="2"/>
               </a:rPr>
               <a:t>NVLink</a:t>
             </a:r>
-            <a:br>
-              <a:rPr lang="en-US" dirty="0">
+            <a:r>
+              <a:rPr lang="en-US" sz="2400" dirty="0">
                 <a:sym typeface="Symbol" panose="05050102010706020507" pitchFamily="18" charset="2"/>
               </a:rPr>
-            </a:br>
-            <a:r>
-              <a:rPr lang="en-US" dirty="0">
+              <a:t>   100 GB/s each way per GPU pair</a:t>
+            </a:r>
+          </a:p>
+          <a:p>
+            <a:r>
+              <a:rPr lang="en-US" sz="2400" dirty="0"/>
+              <a:t>PCIe </a:t>
+            </a:r>
+            <a:r>
+              <a:rPr lang="en-US" sz="2400" dirty="0">
                 <a:sym typeface="Symbol" panose="05050102010706020507" pitchFamily="18" charset="2"/>
               </a:rPr>
-              <a:t>     200 Gb/s</a:t>
-            </a:r>
-          </a:p>
-          <a:p>
-            <a:r>
-              <a:rPr lang="en-US" dirty="0"/>
-              <a:t>PCIe</a:t>
+              <a:t> 32 GB/s each way</a:t>
+            </a:r>
+          </a:p>
+          <a:p>
+            <a:r>
+              <a:rPr lang="en-US" sz="2400" dirty="0"/>
+              <a:t>Host memory</a:t>
             </a:r>
             <a:br>
-              <a:rPr lang="en-US" dirty="0"/>
+              <a:rPr lang="en-US" sz="2400" dirty="0"/>
             </a:br>
             <a:r>
-              <a:rPr lang="en-US" dirty="0"/>
+              <a:rPr lang="en-US" sz="2400" dirty="0"/>
               <a:t>    </a:t>
             </a:r>
             <a:r>
-              <a:rPr lang="en-US" dirty="0">
+              <a:rPr lang="en-US" sz="2400" dirty="0">
                 <a:sym typeface="Symbol" panose="05050102010706020507" pitchFamily="18" charset="2"/>
               </a:rPr>
-              <a:t> 32 Gb/s</a:t>
-            </a:r>
-          </a:p>
-          <a:p>
-            <a:r>
-              <a:rPr lang="en-US" dirty="0"/>
-              <a:t>Host memory</a:t>
-            </a:r>
-            <a:br>
-              <a:rPr lang="en-US" dirty="0"/>
-            </a:br>
-            <a:r>
-              <a:rPr lang="en-US" dirty="0"/>
-              <a:t>    </a:t>
-            </a:r>
-            <a:r>
-              <a:rPr lang="en-US" dirty="0">
+              <a:t> 300 GB/s</a:t>
+            </a:r>
+          </a:p>
+          <a:p>
+            <a:r>
+              <a:rPr lang="en-US" sz="2400" dirty="0">
                 <a:sym typeface="Symbol" panose="05050102010706020507" pitchFamily="18" charset="2"/>
               </a:rPr>
-              <a:t> 300 Gb/s</a:t>
-            </a:r>
-          </a:p>
-          <a:p>
-            <a:r>
-              <a:rPr lang="en-US" dirty="0" err="1">
+              <a:t>HDR </a:t>
+            </a:r>
+            <a:r>
+              <a:rPr lang="en-US" sz="2400" dirty="0" err="1">
                 <a:sym typeface="Symbol" panose="05050102010706020507" pitchFamily="18" charset="2"/>
               </a:rPr>
               <a:t>Infiniband</a:t>
             </a:r>
             <a:r>
-              <a:rPr lang="en-US" dirty="0">
+              <a:rPr lang="en-US" sz="2400" dirty="0">
                 <a:sym typeface="Symbol" panose="05050102010706020507" pitchFamily="18" charset="2"/>
               </a:rPr>
-              <a:t> (HDR)</a:t>
-            </a:r>
-            <a:br>
-              <a:rPr lang="en-US" dirty="0">
-                <a:sym typeface="Symbol" panose="05050102010706020507" pitchFamily="18" charset="2"/>
-              </a:rPr>
-            </a:br>
-            <a:r>
-              <a:rPr lang="en-US" dirty="0">
-                <a:sym typeface="Symbol" panose="05050102010706020507" pitchFamily="18" charset="2"/>
-              </a:rPr>
-              <a:t>     25 Gb/s</a:t>
-            </a:r>
-            <a:endParaRPr lang="LID4096" dirty="0"/>
+              <a:t>  25 GB/s each way per port</a:t>
+            </a:r>
+            <a:endParaRPr lang="LID4096" sz="2400" dirty="0"/>
           </a:p>
         </p:txBody>
       </p:sp>
@@ -10831,7 +10824,7 @@
         </p:nvCxnSpPr>
         <p:spPr>
           <a:xfrm flipH="1">
-            <a:off x="6299039" y="2845855"/>
+            <a:off x="6492079" y="2845855"/>
             <a:ext cx="3645883" cy="9369"/>
           </a:xfrm>
           <a:prstGeom prst="line">
@@ -10872,7 +10865,7 @@
         </p:nvGrpSpPr>
         <p:grpSpPr>
           <a:xfrm>
-            <a:off x="4782813" y="1624545"/>
+            <a:off x="4975853" y="1624545"/>
             <a:ext cx="3078210" cy="4136243"/>
             <a:chOff x="4782813" y="1624545"/>
             <a:chExt cx="3078210" cy="4136243"/>
@@ -12252,7 +12245,7 @@
         </p:nvGrpSpPr>
         <p:grpSpPr>
           <a:xfrm>
-            <a:off x="8741213" y="1624544"/>
+            <a:off x="8934253" y="1624544"/>
             <a:ext cx="3078210" cy="4136243"/>
             <a:chOff x="8428696" y="1624544"/>
             <a:chExt cx="3078210" cy="4136243"/>
@@ -13632,7 +13625,7 @@
         </p:nvSpPr>
         <p:spPr>
           <a:xfrm>
-            <a:off x="7972533" y="2646370"/>
+            <a:off x="8165573" y="2646370"/>
             <a:ext cx="646331" cy="369332"/>
           </a:xfrm>
           <a:prstGeom prst="rect">
@@ -24222,7 +24215,7 @@
             <p:ph idx="1"/>
             <p:extLst>
               <p:ext uri="{D42A27DB-BD31-4B8C-83A1-F6EECF244321}">
-                <p14:modId xmlns:p14="http://schemas.microsoft.com/office/powerpoint/2010/main" val="4219400718"/>
+                <p14:modId xmlns:p14="http://schemas.microsoft.com/office/powerpoint/2010/main" val="4108829723"/>
               </p:ext>
             </p:extLst>
           </p:nvPr>
@@ -24303,7 +24296,7 @@
                     <a:p>
                       <a:r>
                         <a:rPr lang="en-US" dirty="0"/>
-                        <a:t>GPU-GPU bandwidth (Gb/s)</a:t>
+                        <a:t>GPU-GPU bandwidth (GB/s)</a:t>
                       </a:r>
                       <a:endParaRPr lang="LID4096" dirty="0"/>
                     </a:p>
@@ -24317,7 +24310,7 @@
                     <a:p>
                       <a:r>
                         <a:rPr lang="en-US" dirty="0"/>
-                        <a:t>PCIe bandwidth (Gb/s)</a:t>
+                        <a:t>PCIe bandwidth (GB/s)</a:t>
                       </a:r>
                       <a:endParaRPr lang="LID4096" dirty="0"/>
                     </a:p>
@@ -25237,6 +25230,123 @@
       <p:bldP spid="5" grpId="0" animBg="1"/>
     </p:bldLst>
   </p:timing>
+</p:sld>
+</file>
+
+<file path=ppt/slides/slide33.xml><?xml version="1.0" encoding="utf-8"?>
+<p:sld xmlns:a="http://schemas.openxmlformats.org/drawingml/2006/main" xmlns:r="http://schemas.openxmlformats.org/officeDocument/2006/relationships" xmlns:p="http://schemas.openxmlformats.org/presentationml/2006/main">
+  <p:cSld>
+    <p:spTree>
+      <p:nvGrpSpPr>
+        <p:cNvPr id="1" name=""/>
+        <p:cNvGrpSpPr/>
+        <p:nvPr/>
+      </p:nvGrpSpPr>
+      <p:grpSpPr>
+        <a:xfrm>
+          <a:off x="0" y="0"/>
+          <a:ext cx="0" cy="0"/>
+          <a:chOff x="0" y="0"/>
+          <a:chExt cx="0" cy="0"/>
+        </a:xfrm>
+      </p:grpSpPr>
+      <p:sp>
+        <p:nvSpPr>
+          <p:cNvPr id="2" name="Title 1">
+            <a:extLst>
+              <a:ext uri="{FF2B5EF4-FFF2-40B4-BE49-F238E27FC236}">
+                <a16:creationId xmlns:a16="http://schemas.microsoft.com/office/drawing/2014/main" id="{6B3E72AA-9494-55B0-3590-EA81A3C78027}"/>
+              </a:ext>
+            </a:extLst>
+          </p:cNvPr>
+          <p:cNvSpPr>
+            <a:spLocks noGrp="1"/>
+          </p:cNvSpPr>
+          <p:nvPr>
+            <p:ph type="title"/>
+          </p:nvPr>
+        </p:nvSpPr>
+        <p:spPr/>
+        <p:txBody>
+          <a:bodyPr/>
+          <a:lstStyle/>
+          <a:p>
+            <a:r>
+              <a:rPr lang="en-US" dirty="0"/>
+              <a:t>Unit conventions</a:t>
+            </a:r>
+            <a:endParaRPr lang="LID4096" dirty="0"/>
+          </a:p>
+        </p:txBody>
+      </p:sp>
+      <p:sp>
+        <p:nvSpPr>
+          <p:cNvPr id="3" name="Content Placeholder 2">
+            <a:extLst>
+              <a:ext uri="{FF2B5EF4-FFF2-40B4-BE49-F238E27FC236}">
+                <a16:creationId xmlns:a16="http://schemas.microsoft.com/office/drawing/2014/main" id="{F8E20FC5-F6A4-41FF-41B6-46821BD2845A}"/>
+              </a:ext>
+            </a:extLst>
+          </p:cNvPr>
+          <p:cNvSpPr>
+            <a:spLocks noGrp="1"/>
+          </p:cNvSpPr>
+          <p:nvPr>
+            <p:ph idx="1"/>
+          </p:nvPr>
+        </p:nvSpPr>
+        <p:spPr/>
+        <p:txBody>
+          <a:bodyPr/>
+          <a:lstStyle/>
+          <a:p>
+            <a:r>
+              <a:rPr lang="en-US" dirty="0"/>
+              <a:t>GB = gigabytes</a:t>
+            </a:r>
+            <a:endParaRPr lang="LID4096" dirty="0"/>
+          </a:p>
+        </p:txBody>
+      </p:sp>
+      <p:sp>
+        <p:nvSpPr>
+          <p:cNvPr id="4" name="Slide Number Placeholder 3">
+            <a:extLst>
+              <a:ext uri="{FF2B5EF4-FFF2-40B4-BE49-F238E27FC236}">
+                <a16:creationId xmlns:a16="http://schemas.microsoft.com/office/drawing/2014/main" id="{3C4F75D5-1F21-CD5D-19E2-591551BE4AFD}"/>
+              </a:ext>
+            </a:extLst>
+          </p:cNvPr>
+          <p:cNvSpPr>
+            <a:spLocks noGrp="1"/>
+          </p:cNvSpPr>
+          <p:nvPr>
+            <p:ph type="sldNum" sz="quarter" idx="12"/>
+          </p:nvPr>
+        </p:nvSpPr>
+        <p:spPr/>
+        <p:txBody>
+          <a:bodyPr/>
+          <a:lstStyle/>
+          <a:p>
+            <a:fld id="{9C7CE217-4467-4B8D-A735-B008FA7C4816}" type="slidenum">
+              <a:rPr lang="LID4096" smtClean="0"/>
+              <a:t>33</a:t>
+            </a:fld>
+            <a:endParaRPr lang="LID4096"/>
+          </a:p>
+        </p:txBody>
+      </p:sp>
+    </p:spTree>
+    <p:extLst>
+      <p:ext uri="{BB962C8B-B14F-4D97-AF65-F5344CB8AC3E}">
+        <p14:creationId xmlns:p14="http://schemas.microsoft.com/office/powerpoint/2010/main" val="1327888539"/>
+      </p:ext>
+    </p:extLst>
+  </p:cSld>
+  <p:clrMapOvr>
+    <a:masterClrMapping/>
+  </p:clrMapOvr>
 </p:sld>
 </file>
 

</xml_diff>

<commit_message>
Fix SM register count
</commit_message>
<xml_diff>
--- a/gpu_programming.pptx
+++ b/gpu_programming.pptx
@@ -9071,7 +9071,7 @@
             <p:ph idx="1"/>
             <p:extLst>
               <p:ext uri="{D42A27DB-BD31-4B8C-83A1-F6EECF244321}">
-                <p14:modId xmlns:p14="http://schemas.microsoft.com/office/powerpoint/2010/main" val="1569963829"/>
+                <p14:modId xmlns:p14="http://schemas.microsoft.com/office/powerpoint/2010/main" val="99715657"/>
               </p:ext>
             </p:extLst>
           </p:nvPr>
@@ -9266,7 +9266,7 @@
                     <a:p>
                       <a:r>
                         <a:rPr lang="en-US" dirty="0"/>
-                        <a:t>256 K </a:t>
+                        <a:t>64 K </a:t>
                       </a:r>
                       <a:r>
                         <a:rPr lang="en-US" dirty="0">
@@ -21699,7 +21699,7 @@
             <p:ph idx="1"/>
             <p:extLst>
               <p:ext uri="{D42A27DB-BD31-4B8C-83A1-F6EECF244321}">
-                <p14:modId xmlns:p14="http://schemas.microsoft.com/office/powerpoint/2010/main" val="2286944672"/>
+                <p14:modId xmlns:p14="http://schemas.microsoft.com/office/powerpoint/2010/main" val="1239872096"/>
               </p:ext>
             </p:extLst>
           </p:nvPr>
@@ -21911,7 +21911,7 @@
                     <a:p>
                       <a:r>
                         <a:rPr lang="en-US" dirty="0"/>
-                        <a:t>256 K </a:t>
+                        <a:t>64 K </a:t>
                       </a:r>
                       <a:r>
                         <a:rPr lang="en-US" dirty="0">
@@ -21948,7 +21948,7 @@
                       </a:pPr>
                       <a:r>
                         <a:rPr lang="en-US" dirty="0"/>
-                        <a:t>256 K </a:t>
+                        <a:t>64 K </a:t>
                       </a:r>
                       <a:r>
                         <a:rPr lang="en-US" dirty="0">
@@ -21985,7 +21985,7 @@
                       </a:pPr>
                       <a:r>
                         <a:rPr lang="en-US" dirty="0"/>
-                        <a:t>256 K </a:t>
+                        <a:t>64 K </a:t>
                       </a:r>
                       <a:r>
                         <a:rPr lang="en-US" dirty="0">

</xml_diff>

<commit_message>
Fix all P0 issues
</commit_message>
<xml_diff>
--- a/gpu_programming.pptx
+++ b/gpu_programming.pptx
@@ -8530,7 +8530,7 @@
             </a:br>
             <a:r>
               <a:rPr lang="en-US" dirty="0"/>
-              <a:t>64 FP32 instructions/SM </a:t>
+              <a:t>64 FP32 lanes/SM </a:t>
             </a:r>
             <a:r>
               <a:rPr lang="en-US" dirty="0">
@@ -8540,7 +8540,34 @@
             </a:r>
             <a:r>
               <a:rPr lang="en-US" dirty="0"/>
-              <a:t> number SMs = 6,912 FLOP/cycle</a:t>
+              <a:t> 2FLOPS/FMA </a:t>
+            </a:r>
+            <a:r>
+              <a:rPr lang="en-US" dirty="0">
+                <a:sym typeface="Symbol" panose="05050102010706020507" pitchFamily="18" charset="2"/>
+              </a:rPr>
+              <a:t></a:t>
+            </a:r>
+            <a:r>
+              <a:rPr lang="en-US" dirty="0"/>
+              <a:t> number SMs</a:t>
+            </a:r>
+            <a:br>
+              <a:rPr lang="en-US" dirty="0"/>
+            </a:br>
+            <a:r>
+              <a:rPr lang="en-US" dirty="0"/>
+              <a:t>= 13,824 FLOP/cycle </a:t>
+            </a:r>
+            <a:r>
+              <a:rPr lang="en-US" dirty="0">
+                <a:sym typeface="Symbol" panose="05050102010706020507" pitchFamily="18" charset="2"/>
+              </a:rPr>
+              <a:t></a:t>
+            </a:r>
+            <a:r>
+              <a:rPr lang="en-US" dirty="0"/>
+              <a:t> 19.5 TFLOP/s</a:t>
             </a:r>
           </a:p>
           <a:p>
@@ -8591,7 +8618,7 @@
         </p:nvGrpSpPr>
         <p:grpSpPr>
           <a:xfrm>
-            <a:off x="6096000" y="5331337"/>
+            <a:off x="7269941" y="5241644"/>
             <a:ext cx="4083859" cy="935319"/>
             <a:chOff x="4092498" y="4734412"/>
             <a:chExt cx="4083859" cy="935319"/>
@@ -10167,7 +10194,7 @@
             </a:r>
             <a:r>
               <a:rPr lang="en-US" dirty="0"/>
-              <a:t> lanes/GPU </a:t>
+              <a:t> link/GPU </a:t>
             </a:r>
             <a:r>
               <a:rPr lang="en-US" dirty="0">
@@ -10177,14 +10204,14 @@
             </a:r>
             <a:r>
               <a:rPr lang="en-US" dirty="0"/>
-              <a:t> 4 lanes to each GPU</a:t>
+              <a:t> 4 links to each GPU</a:t>
             </a:r>
           </a:p>
           <a:p>
             <a:pPr lvl="2"/>
             <a:r>
               <a:rPr lang="en-US" dirty="0"/>
-              <a:t>50 GB/s/lane (bi-directional) </a:t>
+              <a:t>50 GB/s/link (bi-directional) </a:t>
             </a:r>
             <a:r>
               <a:rPr lang="en-US" dirty="0">
@@ -17397,7 +17424,7 @@
         <p:spPr/>
         <p:txBody>
           <a:bodyPr>
-            <a:normAutofit fontScale="77500" lnSpcReduction="20000"/>
+            <a:normAutofit fontScale="70000" lnSpcReduction="20000"/>
           </a:bodyPr>
           <a:lstStyle/>
           <a:p>
@@ -17443,7 +17470,7 @@
             <a:pPr lvl="1"/>
             <a:r>
               <a:rPr lang="en-US" dirty="0"/>
-              <a:t>At most 32 warps</a:t>
+              <a:t>At most 64 warps resident on SM</a:t>
             </a:r>
           </a:p>
           <a:p>
@@ -17459,7 +17486,7 @@
             </a:r>
             <a:r>
               <a:rPr lang="en-US" dirty="0"/>
-              <a:t> 4 warp instructions/cycle</a:t>
+              <a:t> at most 4 warp instructions/cycle</a:t>
             </a:r>
           </a:p>
           <a:p>
@@ -17474,6 +17501,13 @@
             <a:r>
               <a:rPr lang="en-US" dirty="0"/>
               <a:t>Picked from ready warps</a:t>
+            </a:r>
+          </a:p>
+          <a:p>
+            <a:pPr lvl="1"/>
+            <a:r>
+              <a:rPr lang="en-US" dirty="0"/>
+              <a:t>Number of instructions depends on pipelines used</a:t>
             </a:r>
           </a:p>
           <a:p>
@@ -17600,7 +17634,7 @@
         <p:spPr>
           <a:xfrm>
             <a:off x="7842770" y="1870075"/>
-            <a:ext cx="3721981" cy="830997"/>
+            <a:ext cx="3685111" cy="830997"/>
           </a:xfrm>
           <a:prstGeom prst="rect">
             <a:avLst/>
@@ -17620,7 +17654,7 @@
           <a:p>
             <a:r>
               <a:rPr lang="en-US" sz="2400" dirty="0"/>
-              <a:t>Numbers for NVIDIA H100,</a:t>
+              <a:t>Numbers for NVIDIA A100,</a:t>
             </a:r>
             <a:br>
               <a:rPr lang="en-US" sz="2400" dirty="0"/>
@@ -18030,33 +18064,15 @@
                                   </p:childTnLst>
                                 </p:cTn>
                               </p:par>
-                            </p:childTnLst>
-                          </p:cTn>
-                        </p:par>
-                      </p:childTnLst>
-                    </p:cTn>
-                  </p:par>
-                  <p:par>
-                    <p:cTn id="31" fill="hold">
-                      <p:stCondLst>
-                        <p:cond delay="indefinite"/>
-                      </p:stCondLst>
-                      <p:childTnLst>
-                        <p:par>
-                          <p:cTn id="32" fill="hold">
-                            <p:stCondLst>
-                              <p:cond delay="0"/>
-                            </p:stCondLst>
-                            <p:childTnLst>
                               <p:par>
-                                <p:cTn id="33" presetID="1" presetClass="entr" presetSubtype="0" fill="hold" grpId="0" nodeType="clickEffect">
+                                <p:cTn id="31" presetID="1" presetClass="entr" presetSubtype="0" fill="hold" grpId="0" nodeType="withEffect">
                                   <p:stCondLst>
                                     <p:cond delay="0"/>
                                   </p:stCondLst>
                                   <p:childTnLst>
                                     <p:set>
                                       <p:cBhvr>
-                                        <p:cTn id="34" dur="1" fill="hold">
+                                        <p:cTn id="32" dur="1" fill="hold">
                                           <p:stCondLst>
                                             <p:cond delay="0"/>
                                           </p:stCondLst>
@@ -18079,8 +18095,26 @@
                                   </p:childTnLst>
                                 </p:cTn>
                               </p:par>
+                            </p:childTnLst>
+                          </p:cTn>
+                        </p:par>
+                      </p:childTnLst>
+                    </p:cTn>
+                  </p:par>
+                  <p:par>
+                    <p:cTn id="33" fill="hold">
+                      <p:stCondLst>
+                        <p:cond delay="indefinite"/>
+                      </p:stCondLst>
+                      <p:childTnLst>
+                        <p:par>
+                          <p:cTn id="34" fill="hold">
+                            <p:stCondLst>
+                              <p:cond delay="0"/>
+                            </p:stCondLst>
+                            <p:childTnLst>
                               <p:par>
-                                <p:cTn id="35" presetID="1" presetClass="entr" presetSubtype="0" fill="hold" grpId="0" nodeType="withEffect">
+                                <p:cTn id="35" presetID="1" presetClass="entr" presetSubtype="0" fill="hold" grpId="0" nodeType="clickEffect">
                                   <p:stCondLst>
                                     <p:cond delay="0"/>
                                   </p:stCondLst>
@@ -18172,6 +18206,37 @@
                                   </p:childTnLst>
                                 </p:cTn>
                               </p:par>
+                              <p:par>
+                                <p:cTn id="41" presetID="1" presetClass="entr" presetSubtype="0" fill="hold" grpId="0" nodeType="withEffect">
+                                  <p:stCondLst>
+                                    <p:cond delay="0"/>
+                                  </p:stCondLst>
+                                  <p:childTnLst>
+                                    <p:set>
+                                      <p:cBhvr>
+                                        <p:cTn id="42" dur="1" fill="hold">
+                                          <p:stCondLst>
+                                            <p:cond delay="0"/>
+                                          </p:stCondLst>
+                                        </p:cTn>
+                                        <p:tgtEl>
+                                          <p:spTgt spid="3">
+                                            <p:txEl>
+                                              <p:pRg st="14" end="14"/>
+                                            </p:txEl>
+                                          </p:spTgt>
+                                        </p:tgtEl>
+                                        <p:attrNameLst>
+                                          <p:attrName>style.visibility</p:attrName>
+                                        </p:attrNameLst>
+                                      </p:cBhvr>
+                                      <p:to>
+                                        <p:strVal val="visible"/>
+                                      </p:to>
+                                    </p:set>
+                                  </p:childTnLst>
+                                </p:cTn>
+                              </p:par>
                             </p:childTnLst>
                           </p:cTn>
                         </p:par>
@@ -18179,26 +18244,26 @@
                     </p:cTn>
                   </p:par>
                   <p:par>
-                    <p:cTn id="41" fill="hold">
+                    <p:cTn id="43" fill="hold">
                       <p:stCondLst>
                         <p:cond delay="indefinite"/>
                       </p:stCondLst>
                       <p:childTnLst>
                         <p:par>
-                          <p:cTn id="42" fill="hold">
+                          <p:cTn id="44" fill="hold">
                             <p:stCondLst>
                               <p:cond delay="0"/>
                             </p:stCondLst>
                             <p:childTnLst>
                               <p:par>
-                                <p:cTn id="43" presetID="1" presetClass="entr" presetSubtype="0" fill="hold" grpId="0" nodeType="clickEffect">
+                                <p:cTn id="45" presetID="1" presetClass="entr" presetSubtype="0" fill="hold" grpId="0" nodeType="clickEffect">
                                   <p:stCondLst>
                                     <p:cond delay="0"/>
                                   </p:stCondLst>
                                   <p:childTnLst>
                                     <p:set>
                                       <p:cBhvr>
-                                        <p:cTn id="44" dur="1" fill="hold">
+                                        <p:cTn id="46" dur="1" fill="hold">
                                           <p:stCondLst>
                                             <p:cond delay="0"/>
                                           </p:stCondLst>
@@ -21699,7 +21764,7 @@
             <p:ph idx="1"/>
             <p:extLst>
               <p:ext uri="{D42A27DB-BD31-4B8C-83A1-F6EECF244321}">
-                <p14:modId xmlns:p14="http://schemas.microsoft.com/office/powerpoint/2010/main" val="1239872096"/>
+                <p14:modId xmlns:p14="http://schemas.microsoft.com/office/powerpoint/2010/main" val="910326922"/>
               </p:ext>
             </p:extLst>
           </p:nvPr>
@@ -22081,8 +22146,12 @@
                     <a:lstStyle/>
                     <a:p>
                       <a:r>
+                        <a:rPr lang="en-US"/>
+                        <a:t>228 </a:t>
+                      </a:r>
+                      <a:r>
                         <a:rPr lang="en-US" dirty="0"/>
-                        <a:t>256 KB</a:t>
+                        <a:t>KB</a:t>
                       </a:r>
                       <a:endParaRPr lang="LID4096" dirty="0"/>
                     </a:p>
@@ -22117,7 +22186,7 @@
                     <a:p>
                       <a:r>
                         <a:rPr lang="en-US" dirty="0"/>
-                        <a:t>24Kb</a:t>
+                        <a:t>24 KB</a:t>
                       </a:r>
                       <a:endParaRPr lang="LID4096" dirty="0"/>
                     </a:p>
@@ -22248,7 +22317,7 @@
                     <a:p>
                       <a:r>
                         <a:rPr lang="en-US" dirty="0"/>
-                        <a:t>256-288 KB</a:t>
+                        <a:t>256 KB</a:t>
                       </a:r>
                       <a:endParaRPr lang="LID4096" dirty="0"/>
                     </a:p>
@@ -24167,6 +24236,14 @@
             </a:r>
             <a:r>
               <a:rPr lang="en-US" dirty="0"/>
+              <a:t>/</a:t>
+            </a:r>
+            <a:r>
+              <a:rPr lang="en-US" dirty="0" err="1"/>
+              <a:t>NVSwitch</a:t>
+            </a:r>
+            <a:r>
+              <a:rPr lang="en-US" dirty="0"/>
               <a:t> &amp; PCIe</a:t>
             </a:r>
             <a:endParaRPr lang="LID4096" dirty="0"/>
@@ -24189,14 +24266,14 @@
             <p:ph idx="1"/>
             <p:extLst>
               <p:ext uri="{D42A27DB-BD31-4B8C-83A1-F6EECF244321}">
-                <p14:modId xmlns:p14="http://schemas.microsoft.com/office/powerpoint/2010/main" val="4108829723"/>
+                <p14:modId xmlns:p14="http://schemas.microsoft.com/office/powerpoint/2010/main" val="3792309018"/>
               </p:ext>
             </p:extLst>
           </p:nvPr>
         </p:nvGraphicFramePr>
         <p:xfrm>
           <a:off x="1491475" y="1937137"/>
-          <a:ext cx="9209050" cy="2225040"/>
+          <a:ext cx="9209050" cy="2494280"/>
         </p:xfrm>
         <a:graphic>
           <a:graphicData uri="http://schemas.openxmlformats.org/drawingml/2006/table">
@@ -24272,6 +24349,13 @@
                         <a:rPr lang="en-US" dirty="0"/>
                         <a:t>GPU-GPU bandwidth (GB/s)</a:t>
                       </a:r>
+                      <a:br>
+                        <a:rPr lang="en-US" dirty="0"/>
+                      </a:br>
+                      <a:r>
+                        <a:rPr lang="en-US" dirty="0"/>
+                        <a:t>each way</a:t>
+                      </a:r>
                       <a:endParaRPr lang="LID4096" dirty="0"/>
                     </a:p>
                   </a:txBody>
@@ -24285,6 +24369,13 @@
                       <a:r>
                         <a:rPr lang="en-US" dirty="0"/>
                         <a:t>PCIe bandwidth (GB/s)</a:t>
+                      </a:r>
+                      <a:br>
+                        <a:rPr lang="en-US" dirty="0"/>
+                      </a:br>
+                      <a:r>
+                        <a:rPr lang="en-US" dirty="0"/>
+                        <a:t>each way</a:t>
                       </a:r>
                       <a:endParaRPr lang="LID4096" dirty="0"/>
                     </a:p>
@@ -24333,7 +24424,7 @@
                     <a:p>
                       <a:r>
                         <a:rPr lang="en-US" dirty="0"/>
-                        <a:t>40 to 80 (non-uniform)</a:t>
+                        <a:t>20 to 40 (non-uniform)</a:t>
                       </a:r>
                       <a:endParaRPr lang="LID4096" dirty="0"/>
                     </a:p>
@@ -24347,7 +24438,7 @@
                     <a:p>
                       <a:r>
                         <a:rPr lang="en-US" dirty="0"/>
-                        <a:t>32</a:t>
+                        <a:t>16</a:t>
                       </a:r>
                       <a:endParaRPr lang="LID4096" dirty="0"/>
                     </a:p>
@@ -24396,7 +24487,7 @@
                     <a:p>
                       <a:r>
                         <a:rPr lang="en-US" dirty="0"/>
-                        <a:t>50 (non-uniform)</a:t>
+                        <a:t>25 (non-uniform)</a:t>
                       </a:r>
                       <a:endParaRPr lang="LID4096" dirty="0"/>
                     </a:p>
@@ -24410,7 +24501,7 @@
                     <a:p>
                       <a:r>
                         <a:rPr lang="en-US" dirty="0"/>
-                        <a:t>32</a:t>
+                        <a:t>16</a:t>
                       </a:r>
                       <a:endParaRPr lang="LID4096" dirty="0"/>
                     </a:p>
@@ -24459,7 +24550,7 @@
                     <a:p>
                       <a:r>
                         <a:rPr lang="en-US" dirty="0"/>
-                        <a:t>200</a:t>
+                        <a:t>100</a:t>
                       </a:r>
                       <a:endParaRPr lang="LID4096" dirty="0"/>
                     </a:p>
@@ -24473,7 +24564,7 @@
                     <a:p>
                       <a:r>
                         <a:rPr lang="en-US" dirty="0"/>
-                        <a:t>64</a:t>
+                        <a:t>32</a:t>
                       </a:r>
                       <a:endParaRPr lang="LID4096" dirty="0"/>
                     </a:p>
@@ -24522,7 +24613,7 @@
                     <a:p>
                       <a:r>
                         <a:rPr lang="en-US" dirty="0"/>
-                        <a:t>300</a:t>
+                        <a:t>150</a:t>
                       </a:r>
                       <a:endParaRPr lang="LID4096" dirty="0"/>
                     </a:p>
@@ -24536,7 +24627,7 @@
                     <a:p>
                       <a:r>
                         <a:rPr lang="en-US" dirty="0"/>
-                        <a:t>128</a:t>
+                        <a:t>64</a:t>
                       </a:r>
                       <a:endParaRPr lang="LID4096" dirty="0"/>
                     </a:p>
@@ -24585,7 +24676,7 @@
                     <a:p>
                       <a:r>
                         <a:rPr lang="en-US" dirty="0"/>
-                        <a:t>600</a:t>
+                        <a:t>900</a:t>
                       </a:r>
                       <a:endParaRPr lang="LID4096" dirty="0"/>
                     </a:p>
@@ -24599,7 +24690,7 @@
                     <a:p>
                       <a:r>
                         <a:rPr lang="en-US" dirty="0"/>
-                        <a:t>128</a:t>
+                        <a:t>64</a:t>
                       </a:r>
                       <a:endParaRPr lang="LID4096" dirty="0"/>
                     </a:p>

</xml_diff>

<commit_message>
Update data placement slide
</commit_message>
<xml_diff>
--- a/gpu_programming.pptx
+++ b/gpu_programming.pptx
@@ -12914,7 +12914,7 @@
           <a:p>
             <a:r>
               <a:rPr lang="en-US" dirty="0"/>
-              <a:t>Memory management</a:t>
+              <a:t>Data placement</a:t>
             </a:r>
             <a:endParaRPr lang="LID4096" dirty="0"/>
           </a:p>
@@ -12936,44 +12936,55 @@
             <p:ph idx="1"/>
           </p:nvPr>
         </p:nvSpPr>
-        <p:spPr/>
+        <p:spPr>
+          <a:xfrm>
+            <a:off x="828368" y="3790813"/>
+            <a:ext cx="10515600" cy="2386150"/>
+          </a:xfrm>
+        </p:spPr>
         <p:txBody>
           <a:bodyPr>
-            <a:normAutofit fontScale="92500" lnSpcReduction="20000"/>
+            <a:normAutofit lnSpcReduction="10000"/>
           </a:bodyPr>
           <a:lstStyle/>
           <a:p>
             <a:r>
               <a:rPr lang="en-US" dirty="0"/>
-              <a:t>Explicit memory management</a:t>
+              <a:t>Making data available</a:t>
             </a:r>
           </a:p>
           <a:p>
             <a:pPr lvl="1"/>
             <a:r>
               <a:rPr lang="en-US" dirty="0"/>
-              <a:t>Memory allocation/deallocation</a:t>
+              <a:t>Explicit copy</a:t>
             </a:r>
           </a:p>
           <a:p>
             <a:pPr lvl="1"/>
             <a:r>
               <a:rPr lang="en-US" dirty="0"/>
-              <a:t>Host versus device addresses</a:t>
+              <a:t>Run-time managed migration</a:t>
             </a:r>
           </a:p>
           <a:p>
             <a:pPr lvl="1"/>
             <a:r>
               <a:rPr lang="en-US" dirty="0"/>
-              <a:t>Explicit  copy</a:t>
-            </a:r>
-          </a:p>
-          <a:p>
-            <a:pPr lvl="2"/>
+              <a:t>Coherent direct/remote access</a:t>
+            </a:r>
+          </a:p>
+          <a:p>
             <a:r>
               <a:rPr lang="en-US" dirty="0"/>
-              <a:t>Host </a:t>
+              <a:t>Correctness:</a:t>
+            </a:r>
+            <a:br>
+              <a:rPr lang="en-US" dirty="0"/>
+            </a:br>
+            <a:r>
+              <a:rPr lang="en-US" dirty="0"/>
+              <a:t>producer </a:t>
             </a:r>
             <a:r>
               <a:rPr lang="en-US" dirty="0">
@@ -12983,14 +12994,7 @@
             </a:r>
             <a:r>
               <a:rPr lang="en-US" dirty="0"/>
-              <a:t> device</a:t>
-            </a:r>
-          </a:p>
-          <a:p>
-            <a:pPr lvl="2"/>
-            <a:r>
-              <a:rPr lang="en-US" dirty="0"/>
-              <a:t>Device </a:t>
+              <a:t> dependency/synchronization </a:t>
             </a:r>
             <a:r>
               <a:rPr lang="en-US" dirty="0">
@@ -13000,69 +13004,7 @@
             </a:r>
             <a:r>
               <a:rPr lang="en-US" dirty="0"/>
-              <a:t> host</a:t>
-            </a:r>
-          </a:p>
-          <a:p>
-            <a:pPr lvl="2"/>
-            <a:r>
-              <a:rPr lang="en-US" dirty="0"/>
-              <a:t>Device </a:t>
-            </a:r>
-            <a:r>
-              <a:rPr lang="en-US" dirty="0">
-                <a:sym typeface="Symbol" panose="05050102010706020507" pitchFamily="18" charset="2"/>
-              </a:rPr>
-              <a:t>  </a:t>
-            </a:r>
-            <a:r>
-              <a:rPr lang="en-US" dirty="0"/>
-              <a:t>device</a:t>
-            </a:r>
-          </a:p>
-          <a:p>
-            <a:pPr lvl="1"/>
-            <a:r>
-              <a:rPr lang="en-US" dirty="0"/>
-              <a:t>Explicit synchronization</a:t>
-            </a:r>
-          </a:p>
-          <a:p>
-            <a:pPr lvl="1"/>
-            <a:endParaRPr lang="en-US" dirty="0"/>
-          </a:p>
-          <a:p>
-            <a:r>
-              <a:rPr lang="en-US" dirty="0"/>
-              <a:t>Unified memory management</a:t>
-            </a:r>
-          </a:p>
-          <a:p>
-            <a:pPr lvl="1"/>
-            <a:r>
-              <a:rPr lang="en-US" dirty="0"/>
-              <a:t>Memory allocation/deallocation </a:t>
-            </a:r>
-          </a:p>
-          <a:p>
-            <a:pPr lvl="1"/>
-            <a:r>
-              <a:rPr lang="en-US" dirty="0"/>
-              <a:t>Single address space</a:t>
-            </a:r>
-          </a:p>
-          <a:p>
-            <a:pPr lvl="1"/>
-            <a:r>
-              <a:rPr lang="en-US" dirty="0"/>
-              <a:t>Implicit data migration (page fault/page copy)</a:t>
-            </a:r>
-          </a:p>
-          <a:p>
-            <a:pPr lvl="1"/>
-            <a:r>
-              <a:rPr lang="en-US" dirty="0"/>
-              <a:t>Explicit synchronization</a:t>
+              <a:t> consumer</a:t>
             </a:r>
             <a:endParaRPr lang="LID4096" dirty="0"/>
           </a:p>
@@ -13111,10 +13053,10 @@
         </p:nvGrpSpPr>
         <p:grpSpPr>
           <a:xfrm>
-            <a:off x="6779941" y="1913153"/>
-            <a:ext cx="4252047" cy="1304651"/>
-            <a:chOff x="6779941" y="1913153"/>
-            <a:chExt cx="4252047" cy="1304651"/>
+            <a:off x="6835812" y="3611426"/>
+            <a:ext cx="4306303" cy="1236096"/>
+            <a:chOff x="6779941" y="1981708"/>
+            <a:chExt cx="4306303" cy="1236096"/>
           </a:xfrm>
         </p:grpSpPr>
         <p:sp>
@@ -13132,7 +13074,7 @@
           <p:spPr>
             <a:xfrm>
               <a:off x="6779941" y="2263697"/>
-              <a:ext cx="3968972" cy="954107"/>
+              <a:ext cx="3886577" cy="954107"/>
             </a:xfrm>
             <a:prstGeom prst="rect">
               <a:avLst/>
@@ -13152,14 +13094,13 @@
             <a:p>
               <a:r>
                 <a:rPr lang="en-US" sz="2800" dirty="0"/>
-                <a:t>More control, potentially</a:t>
+                <a:t>Physical placement</a:t>
               </a:r>
-              <a:br>
-                <a:rPr lang="en-US" sz="2800" dirty="0"/>
-              </a:br>
+            </a:p>
+            <a:p>
               <a:r>
                 <a:rPr lang="en-US" sz="2800" dirty="0"/>
-                <a:t>better performance</a:t>
+                <a:t>influences performance</a:t>
               </a:r>
               <a:endParaRPr lang="LID4096" sz="2800" dirty="0"/>
             </a:p>
@@ -13193,7 +13134,7 @@
           </p:blipFill>
           <p:spPr>
             <a:xfrm>
-              <a:off x="10465837" y="1913153"/>
+              <a:off x="10520093" y="1981708"/>
               <a:ext cx="566151" cy="566151"/>
             </a:xfrm>
             <a:prstGeom prst="rect">
@@ -13204,10 +13145,10 @@
       </p:grpSp>
       <p:sp>
         <p:nvSpPr>
-          <p:cNvPr id="8" name="Rectangle: Rounded Corners 7">
+          <p:cNvPr id="10" name="Rectangle: Rounded Corners 9">
             <a:extLst>
               <a:ext uri="{FF2B5EF4-FFF2-40B4-BE49-F238E27FC236}">
-                <a16:creationId xmlns:a16="http://schemas.microsoft.com/office/drawing/2014/main" id="{8A8F5C80-A544-0FC0-1FB4-9858900E196E}"/>
+                <a16:creationId xmlns:a16="http://schemas.microsoft.com/office/drawing/2014/main" id="{A18C2E28-5205-4A99-8C35-BCFF7BF25C57}"/>
               </a:ext>
             </a:extLst>
           </p:cNvPr>
@@ -13216,22 +13157,62 @@
         </p:nvSpPr>
         <p:spPr>
           <a:xfrm>
-            <a:off x="1550019" y="5754030"/>
-            <a:ext cx="2977375" cy="312233"/>
+            <a:off x="847837" y="1957304"/>
+            <a:ext cx="1140541" cy="481781"/>
           </a:xfrm>
           <a:prstGeom prst="roundRect">
             <a:avLst/>
           </a:prstGeom>
-          <a:solidFill>
-            <a:srgbClr val="FF0000">
-              <a:alpha val="44000"/>
-            </a:srgbClr>
-          </a:solidFill>
-          <a:ln>
-            <a:solidFill>
-              <a:srgbClr val="FF0000"/>
-            </a:solidFill>
-          </a:ln>
+        </p:spPr>
+        <p:style>
+          <a:lnRef idx="2">
+            <a:schemeClr val="accent2">
+              <a:shade val="15000"/>
+            </a:schemeClr>
+          </a:lnRef>
+          <a:fillRef idx="1">
+            <a:schemeClr val="accent2"/>
+          </a:fillRef>
+          <a:effectRef idx="0">
+            <a:schemeClr val="accent2"/>
+          </a:effectRef>
+          <a:fontRef idx="minor">
+            <a:schemeClr val="lt1"/>
+          </a:fontRef>
+        </p:style>
+        <p:txBody>
+          <a:bodyPr rtlCol="0" anchor="ctr"/>
+          <a:lstStyle/>
+          <a:p>
+            <a:pPr algn="ctr"/>
+            <a:r>
+              <a:rPr lang="en-US" dirty="0"/>
+              <a:t>CPU</a:t>
+            </a:r>
+            <a:endParaRPr lang="LID4096" dirty="0"/>
+          </a:p>
+        </p:txBody>
+      </p:sp>
+      <p:sp>
+        <p:nvSpPr>
+          <p:cNvPr id="11" name="Rectangle: Rounded Corners 10">
+            <a:extLst>
+              <a:ext uri="{FF2B5EF4-FFF2-40B4-BE49-F238E27FC236}">
+                <a16:creationId xmlns:a16="http://schemas.microsoft.com/office/drawing/2014/main" id="{41A2B143-13C3-A523-0B20-8BAD1D9A6E10}"/>
+              </a:ext>
+            </a:extLst>
+          </p:cNvPr>
+          <p:cNvSpPr/>
+          <p:nvPr/>
+        </p:nvSpPr>
+        <p:spPr>
+          <a:xfrm>
+            <a:off x="2622626" y="1870076"/>
+            <a:ext cx="1789469" cy="656236"/>
+          </a:xfrm>
+          <a:prstGeom prst="roundRect">
+            <a:avLst/>
+          </a:prstGeom>
         </p:spPr>
         <p:style>
           <a:lnRef idx="2">
@@ -13254,16 +13235,58 @@
           <a:lstStyle/>
           <a:p>
             <a:pPr algn="ctr"/>
-            <a:endParaRPr lang="LID4096"/>
+            <a:r>
+              <a:rPr lang="en-US" dirty="0"/>
+              <a:t>Host-attached memory</a:t>
+            </a:r>
+            <a:endParaRPr lang="LID4096" dirty="0"/>
           </a:p>
         </p:txBody>
       </p:sp>
+      <p:cxnSp>
+        <p:nvCxnSpPr>
+          <p:cNvPr id="12" name="Straight Connector 11">
+            <a:extLst>
+              <a:ext uri="{FF2B5EF4-FFF2-40B4-BE49-F238E27FC236}">
+                <a16:creationId xmlns:a16="http://schemas.microsoft.com/office/drawing/2014/main" id="{A0B8E717-008A-A058-AA25-76AD833C06E1}"/>
+              </a:ext>
+            </a:extLst>
+          </p:cNvPr>
+          <p:cNvCxnSpPr>
+            <a:cxnSpLocks/>
+          </p:cNvCxnSpPr>
+          <p:nvPr/>
+        </p:nvCxnSpPr>
+        <p:spPr>
+          <a:xfrm flipH="1">
+            <a:off x="1988378" y="2154581"/>
+            <a:ext cx="634248" cy="1"/>
+          </a:xfrm>
+          <a:prstGeom prst="line">
+            <a:avLst/>
+          </a:prstGeom>
+        </p:spPr>
+        <p:style>
+          <a:lnRef idx="2">
+            <a:schemeClr val="accent1"/>
+          </a:lnRef>
+          <a:fillRef idx="0">
+            <a:schemeClr val="accent1"/>
+          </a:fillRef>
+          <a:effectRef idx="1">
+            <a:schemeClr val="accent1"/>
+          </a:effectRef>
+          <a:fontRef idx="minor">
+            <a:schemeClr val="tx1"/>
+          </a:fontRef>
+        </p:style>
+      </p:cxnSp>
       <p:sp>
         <p:nvSpPr>
-          <p:cNvPr id="9" name="Rectangle: Rounded Corners 8">
+          <p:cNvPr id="18" name="Rectangle: Rounded Corners 17">
             <a:extLst>
               <a:ext uri="{FF2B5EF4-FFF2-40B4-BE49-F238E27FC236}">
-                <a16:creationId xmlns:a16="http://schemas.microsoft.com/office/drawing/2014/main" id="{E7A8C194-A20D-DCC5-2FD5-6F69B174B5F1}"/>
+                <a16:creationId xmlns:a16="http://schemas.microsoft.com/office/drawing/2014/main" id="{1D67C01E-C834-07BD-6BBA-82FABBBFF1BB}"/>
               </a:ext>
             </a:extLst>
           </p:cNvPr>
@@ -13272,22 +13295,12 @@
         </p:nvSpPr>
         <p:spPr>
           <a:xfrm>
-            <a:off x="1550019" y="4847064"/>
-            <a:ext cx="3980986" cy="312233"/>
+            <a:off x="5046343" y="1870076"/>
+            <a:ext cx="1789469" cy="656236"/>
           </a:xfrm>
           <a:prstGeom prst="roundRect">
             <a:avLst/>
           </a:prstGeom>
-          <a:solidFill>
-            <a:srgbClr val="FF0000">
-              <a:alpha val="44000"/>
-            </a:srgbClr>
-          </a:solidFill>
-          <a:ln>
-            <a:solidFill>
-              <a:srgbClr val="FF0000"/>
-            </a:solidFill>
-          </a:ln>
         </p:spPr>
         <p:style>
           <a:lnRef idx="2">
@@ -13310,7 +13323,177 @@
           <a:lstStyle/>
           <a:p>
             <a:pPr algn="ctr"/>
-            <a:endParaRPr lang="LID4096"/>
+            <a:r>
+              <a:rPr lang="en-US" dirty="0"/>
+              <a:t>Device-local memory</a:t>
+            </a:r>
+            <a:endParaRPr lang="LID4096" dirty="0"/>
+          </a:p>
+        </p:txBody>
+      </p:sp>
+      <p:cxnSp>
+        <p:nvCxnSpPr>
+          <p:cNvPr id="19" name="Straight Connector 18">
+            <a:extLst>
+              <a:ext uri="{FF2B5EF4-FFF2-40B4-BE49-F238E27FC236}">
+                <a16:creationId xmlns:a16="http://schemas.microsoft.com/office/drawing/2014/main" id="{42DE77CF-49C0-2C12-D1BA-4F411117EA28}"/>
+              </a:ext>
+            </a:extLst>
+          </p:cNvPr>
+          <p:cNvCxnSpPr>
+            <a:cxnSpLocks/>
+          </p:cNvCxnSpPr>
+          <p:nvPr/>
+        </p:nvCxnSpPr>
+        <p:spPr>
+          <a:xfrm flipH="1">
+            <a:off x="4412095" y="2198194"/>
+            <a:ext cx="634248" cy="0"/>
+          </a:xfrm>
+          <a:prstGeom prst="line">
+            <a:avLst/>
+          </a:prstGeom>
+          <a:ln>
+            <a:headEnd type="stealth" w="lg" len="lg"/>
+            <a:tailEnd type="stealth" w="lg" len="lg"/>
+          </a:ln>
+        </p:spPr>
+        <p:style>
+          <a:lnRef idx="2">
+            <a:schemeClr val="accent1"/>
+          </a:lnRef>
+          <a:fillRef idx="0">
+            <a:schemeClr val="accent1"/>
+          </a:fillRef>
+          <a:effectRef idx="1">
+            <a:schemeClr val="accent1"/>
+          </a:effectRef>
+          <a:fontRef idx="minor">
+            <a:schemeClr val="tx1"/>
+          </a:fontRef>
+        </p:style>
+      </p:cxnSp>
+      <p:sp>
+        <p:nvSpPr>
+          <p:cNvPr id="21" name="Rectangle: Rounded Corners 20">
+            <a:extLst>
+              <a:ext uri="{FF2B5EF4-FFF2-40B4-BE49-F238E27FC236}">
+                <a16:creationId xmlns:a16="http://schemas.microsoft.com/office/drawing/2014/main" id="{4209ECE4-16B5-81B2-5CEE-02CBF2BB0A80}"/>
+              </a:ext>
+            </a:extLst>
+          </p:cNvPr>
+          <p:cNvSpPr/>
+          <p:nvPr/>
+        </p:nvSpPr>
+        <p:spPr>
+          <a:xfrm>
+            <a:off x="7470059" y="1957304"/>
+            <a:ext cx="1140541" cy="481781"/>
+          </a:xfrm>
+          <a:prstGeom prst="roundRect">
+            <a:avLst/>
+          </a:prstGeom>
+        </p:spPr>
+        <p:style>
+          <a:lnRef idx="2">
+            <a:schemeClr val="accent2">
+              <a:shade val="15000"/>
+            </a:schemeClr>
+          </a:lnRef>
+          <a:fillRef idx="1">
+            <a:schemeClr val="accent2"/>
+          </a:fillRef>
+          <a:effectRef idx="0">
+            <a:schemeClr val="accent2"/>
+          </a:effectRef>
+          <a:fontRef idx="minor">
+            <a:schemeClr val="lt1"/>
+          </a:fontRef>
+        </p:style>
+        <p:txBody>
+          <a:bodyPr rtlCol="0" anchor="ctr"/>
+          <a:lstStyle/>
+          <a:p>
+            <a:pPr algn="ctr"/>
+            <a:r>
+              <a:rPr lang="en-US" dirty="0"/>
+              <a:t>GPU</a:t>
+            </a:r>
+            <a:endParaRPr lang="LID4096" dirty="0"/>
+          </a:p>
+        </p:txBody>
+      </p:sp>
+      <p:cxnSp>
+        <p:nvCxnSpPr>
+          <p:cNvPr id="22" name="Straight Connector 21">
+            <a:extLst>
+              <a:ext uri="{FF2B5EF4-FFF2-40B4-BE49-F238E27FC236}">
+                <a16:creationId xmlns:a16="http://schemas.microsoft.com/office/drawing/2014/main" id="{C4031E85-25F9-D2D9-A3D6-61B303C11BC1}"/>
+              </a:ext>
+            </a:extLst>
+          </p:cNvPr>
+          <p:cNvCxnSpPr>
+            <a:cxnSpLocks/>
+          </p:cNvCxnSpPr>
+          <p:nvPr/>
+        </p:nvCxnSpPr>
+        <p:spPr>
+          <a:xfrm>
+            <a:off x="6835812" y="2154581"/>
+            <a:ext cx="634247" cy="1"/>
+          </a:xfrm>
+          <a:prstGeom prst="line">
+            <a:avLst/>
+          </a:prstGeom>
+        </p:spPr>
+        <p:style>
+          <a:lnRef idx="2">
+            <a:schemeClr val="accent1"/>
+          </a:lnRef>
+          <a:fillRef idx="0">
+            <a:schemeClr val="accent1"/>
+          </a:fillRef>
+          <a:effectRef idx="1">
+            <a:schemeClr val="accent1"/>
+          </a:effectRef>
+          <a:fontRef idx="minor">
+            <a:schemeClr val="tx1"/>
+          </a:fontRef>
+        </p:style>
+      </p:cxnSp>
+      <p:sp>
+        <p:nvSpPr>
+          <p:cNvPr id="25" name="TextBox 24">
+            <a:extLst>
+              <a:ext uri="{FF2B5EF4-FFF2-40B4-BE49-F238E27FC236}">
+                <a16:creationId xmlns:a16="http://schemas.microsoft.com/office/drawing/2014/main" id="{750EDFA0-29F4-7C8C-BE8D-C11369749DA9}"/>
+              </a:ext>
+            </a:extLst>
+          </p:cNvPr>
+          <p:cNvSpPr txBox="1"/>
+          <p:nvPr/>
+        </p:nvSpPr>
+        <p:spPr>
+          <a:xfrm>
+            <a:off x="3873909" y="2665812"/>
+            <a:ext cx="1775166" cy="369332"/>
+          </a:xfrm>
+          <a:prstGeom prst="rect">
+            <a:avLst/>
+          </a:prstGeom>
+          <a:noFill/>
+        </p:spPr>
+        <p:txBody>
+          <a:bodyPr wrap="none" rtlCol="0">
+            <a:spAutoFit/>
+          </a:bodyPr>
+          <a:lstStyle/>
+          <a:p>
+            <a:r>
+              <a:rPr lang="en-US" dirty="0"/>
+              <a:t>Data movement</a:t>
+            </a:r>
+            <a:endParaRPr lang="LID4096" dirty="0"/>
           </a:p>
         </p:txBody>
       </p:sp>
@@ -13525,15 +13708,33 @@
                                   </p:childTnLst>
                                 </p:cTn>
                               </p:par>
+                            </p:childTnLst>
+                          </p:cTn>
+                        </p:par>
+                      </p:childTnLst>
+                    </p:cTn>
+                  </p:par>
+                  <p:par>
+                    <p:cTn id="19" fill="hold">
+                      <p:stCondLst>
+                        <p:cond delay="indefinite"/>
+                      </p:stCondLst>
+                      <p:childTnLst>
+                        <p:par>
+                          <p:cTn id="20" fill="hold">
+                            <p:stCondLst>
+                              <p:cond delay="0"/>
+                            </p:stCondLst>
+                            <p:childTnLst>
                               <p:par>
-                                <p:cTn id="19" presetID="1" presetClass="entr" presetSubtype="0" fill="hold" grpId="0" nodeType="withEffect">
+                                <p:cTn id="21" presetID="1" presetClass="entr" presetSubtype="0" fill="hold" grpId="0" nodeType="clickEffect">
                                   <p:stCondLst>
                                     <p:cond delay="0"/>
                                   </p:stCondLst>
                                   <p:childTnLst>
                                     <p:set>
                                       <p:cBhvr>
-                                        <p:cTn id="20" dur="1" fill="hold">
+                                        <p:cTn id="22" dur="1" fill="hold">
                                           <p:stCondLst>
                                             <p:cond delay="0"/>
                                           </p:stCondLst>
@@ -13556,68 +13757,6 @@
                                   </p:childTnLst>
                                 </p:cTn>
                               </p:par>
-                              <p:par>
-                                <p:cTn id="21" presetID="1" presetClass="entr" presetSubtype="0" fill="hold" grpId="0" nodeType="withEffect">
-                                  <p:stCondLst>
-                                    <p:cond delay="0"/>
-                                  </p:stCondLst>
-                                  <p:childTnLst>
-                                    <p:set>
-                                      <p:cBhvr>
-                                        <p:cTn id="22" dur="1" fill="hold">
-                                          <p:stCondLst>
-                                            <p:cond delay="0"/>
-                                          </p:stCondLst>
-                                        </p:cTn>
-                                        <p:tgtEl>
-                                          <p:spTgt spid="3">
-                                            <p:txEl>
-                                              <p:pRg st="5" end="5"/>
-                                            </p:txEl>
-                                          </p:spTgt>
-                                        </p:tgtEl>
-                                        <p:attrNameLst>
-                                          <p:attrName>style.visibility</p:attrName>
-                                        </p:attrNameLst>
-                                      </p:cBhvr>
-                                      <p:to>
-                                        <p:strVal val="visible"/>
-                                      </p:to>
-                                    </p:set>
-                                  </p:childTnLst>
-                                </p:cTn>
-                              </p:par>
-                              <p:par>
-                                <p:cTn id="23" presetID="1" presetClass="entr" presetSubtype="0" fill="hold" grpId="0" nodeType="withEffect">
-                                  <p:stCondLst>
-                                    <p:cond delay="0"/>
-                                  </p:stCondLst>
-                                  <p:childTnLst>
-                                    <p:set>
-                                      <p:cBhvr>
-                                        <p:cTn id="24" dur="1" fill="hold">
-                                          <p:stCondLst>
-                                            <p:cond delay="0"/>
-                                          </p:stCondLst>
-                                        </p:cTn>
-                                        <p:tgtEl>
-                                          <p:spTgt spid="3">
-                                            <p:txEl>
-                                              <p:pRg st="6" end="6"/>
-                                            </p:txEl>
-                                          </p:spTgt>
-                                        </p:tgtEl>
-                                        <p:attrNameLst>
-                                          <p:attrName>style.visibility</p:attrName>
-                                        </p:attrNameLst>
-                                      </p:cBhvr>
-                                      <p:to>
-                                        <p:strVal val="visible"/>
-                                      </p:to>
-                                    </p:set>
-                                  </p:childTnLst>
-                                </p:cTn>
-                              </p:par>
                             </p:childTnLst>
                           </p:cTn>
                         </p:par>
@@ -13625,410 +13764,26 @@
                     </p:cTn>
                   </p:par>
                   <p:par>
-                    <p:cTn id="25" fill="hold">
+                    <p:cTn id="23" fill="hold">
                       <p:stCondLst>
                         <p:cond delay="indefinite"/>
                       </p:stCondLst>
                       <p:childTnLst>
                         <p:par>
-                          <p:cTn id="26" fill="hold">
+                          <p:cTn id="24" fill="hold">
                             <p:stCondLst>
                               <p:cond delay="0"/>
                             </p:stCondLst>
                             <p:childTnLst>
                               <p:par>
-                                <p:cTn id="27" presetID="1" presetClass="entr" presetSubtype="0" fill="hold" grpId="0" nodeType="clickEffect">
+                                <p:cTn id="25" presetID="1" presetClass="entr" presetSubtype="0" fill="hold" nodeType="clickEffect">
                                   <p:stCondLst>
                                     <p:cond delay="0"/>
                                   </p:stCondLst>
                                   <p:childTnLst>
                                     <p:set>
                                       <p:cBhvr>
-                                        <p:cTn id="28" dur="1" fill="hold">
-                                          <p:stCondLst>
-                                            <p:cond delay="0"/>
-                                          </p:stCondLst>
-                                        </p:cTn>
-                                        <p:tgtEl>
-                                          <p:spTgt spid="3">
-                                            <p:txEl>
-                                              <p:pRg st="7" end="7"/>
-                                            </p:txEl>
-                                          </p:spTgt>
-                                        </p:tgtEl>
-                                        <p:attrNameLst>
-                                          <p:attrName>style.visibility</p:attrName>
-                                        </p:attrNameLst>
-                                      </p:cBhvr>
-                                      <p:to>
-                                        <p:strVal val="visible"/>
-                                      </p:to>
-                                    </p:set>
-                                  </p:childTnLst>
-                                </p:cTn>
-                              </p:par>
-                            </p:childTnLst>
-                          </p:cTn>
-                        </p:par>
-                      </p:childTnLst>
-                    </p:cTn>
-                  </p:par>
-                  <p:par>
-                    <p:cTn id="29" fill="hold">
-                      <p:stCondLst>
-                        <p:cond delay="indefinite"/>
-                      </p:stCondLst>
-                      <p:childTnLst>
-                        <p:par>
-                          <p:cTn id="30" fill="hold">
-                            <p:stCondLst>
-                              <p:cond delay="0"/>
-                            </p:stCondLst>
-                            <p:childTnLst>
-                              <p:par>
-                                <p:cTn id="31" presetID="1" presetClass="entr" presetSubtype="0" fill="hold" grpId="0" nodeType="clickEffect">
-                                  <p:stCondLst>
-                                    <p:cond delay="0"/>
-                                  </p:stCondLst>
-                                  <p:childTnLst>
-                                    <p:set>
-                                      <p:cBhvr>
-                                        <p:cTn id="32" dur="1" fill="hold">
-                                          <p:stCondLst>
-                                            <p:cond delay="0"/>
-                                          </p:stCondLst>
-                                        </p:cTn>
-                                        <p:tgtEl>
-                                          <p:spTgt spid="3">
-                                            <p:txEl>
-                                              <p:pRg st="9" end="9"/>
-                                            </p:txEl>
-                                          </p:spTgt>
-                                        </p:tgtEl>
-                                        <p:attrNameLst>
-                                          <p:attrName>style.visibility</p:attrName>
-                                        </p:attrNameLst>
-                                      </p:cBhvr>
-                                      <p:to>
-                                        <p:strVal val="visible"/>
-                                      </p:to>
-                                    </p:set>
-                                  </p:childTnLst>
-                                </p:cTn>
-                              </p:par>
-                            </p:childTnLst>
-                          </p:cTn>
-                        </p:par>
-                      </p:childTnLst>
-                    </p:cTn>
-                  </p:par>
-                  <p:par>
-                    <p:cTn id="33" fill="hold">
-                      <p:stCondLst>
-                        <p:cond delay="indefinite"/>
-                      </p:stCondLst>
-                      <p:childTnLst>
-                        <p:par>
-                          <p:cTn id="34" fill="hold">
-                            <p:stCondLst>
-                              <p:cond delay="0"/>
-                            </p:stCondLst>
-                            <p:childTnLst>
-                              <p:par>
-                                <p:cTn id="35" presetID="1" presetClass="entr" presetSubtype="0" fill="hold" grpId="0" nodeType="clickEffect">
-                                  <p:stCondLst>
-                                    <p:cond delay="0"/>
-                                  </p:stCondLst>
-                                  <p:childTnLst>
-                                    <p:set>
-                                      <p:cBhvr>
-                                        <p:cTn id="36" dur="1" fill="hold">
-                                          <p:stCondLst>
-                                            <p:cond delay="0"/>
-                                          </p:stCondLst>
-                                        </p:cTn>
-                                        <p:tgtEl>
-                                          <p:spTgt spid="3">
-                                            <p:txEl>
-                                              <p:pRg st="10" end="10"/>
-                                            </p:txEl>
-                                          </p:spTgt>
-                                        </p:tgtEl>
-                                        <p:attrNameLst>
-                                          <p:attrName>style.visibility</p:attrName>
-                                        </p:attrNameLst>
-                                      </p:cBhvr>
-                                      <p:to>
-                                        <p:strVal val="visible"/>
-                                      </p:to>
-                                    </p:set>
-                                  </p:childTnLst>
-                                </p:cTn>
-                              </p:par>
-                            </p:childTnLst>
-                          </p:cTn>
-                        </p:par>
-                      </p:childTnLst>
-                    </p:cTn>
-                  </p:par>
-                  <p:par>
-                    <p:cTn id="37" fill="hold">
-                      <p:stCondLst>
-                        <p:cond delay="indefinite"/>
-                      </p:stCondLst>
-                      <p:childTnLst>
-                        <p:par>
-                          <p:cTn id="38" fill="hold">
-                            <p:stCondLst>
-                              <p:cond delay="0"/>
-                            </p:stCondLst>
-                            <p:childTnLst>
-                              <p:par>
-                                <p:cTn id="39" presetID="1" presetClass="entr" presetSubtype="0" fill="hold" grpId="0" nodeType="clickEffect">
-                                  <p:stCondLst>
-                                    <p:cond delay="0"/>
-                                  </p:stCondLst>
-                                  <p:childTnLst>
-                                    <p:set>
-                                      <p:cBhvr>
-                                        <p:cTn id="40" dur="1" fill="hold">
-                                          <p:stCondLst>
-                                            <p:cond delay="0"/>
-                                          </p:stCondLst>
-                                        </p:cTn>
-                                        <p:tgtEl>
-                                          <p:spTgt spid="3">
-                                            <p:txEl>
-                                              <p:pRg st="11" end="11"/>
-                                            </p:txEl>
-                                          </p:spTgt>
-                                        </p:tgtEl>
-                                        <p:attrNameLst>
-                                          <p:attrName>style.visibility</p:attrName>
-                                        </p:attrNameLst>
-                                      </p:cBhvr>
-                                      <p:to>
-                                        <p:strVal val="visible"/>
-                                      </p:to>
-                                    </p:set>
-                                  </p:childTnLst>
-                                </p:cTn>
-                              </p:par>
-                            </p:childTnLst>
-                          </p:cTn>
-                        </p:par>
-                      </p:childTnLst>
-                    </p:cTn>
-                  </p:par>
-                  <p:par>
-                    <p:cTn id="41" fill="hold">
-                      <p:stCondLst>
-                        <p:cond delay="indefinite"/>
-                      </p:stCondLst>
-                      <p:childTnLst>
-                        <p:par>
-                          <p:cTn id="42" fill="hold">
-                            <p:stCondLst>
-                              <p:cond delay="0"/>
-                            </p:stCondLst>
-                            <p:childTnLst>
-                              <p:par>
-                                <p:cTn id="43" presetID="1" presetClass="entr" presetSubtype="0" fill="hold" grpId="0" nodeType="clickEffect">
-                                  <p:stCondLst>
-                                    <p:cond delay="0"/>
-                                  </p:stCondLst>
-                                  <p:childTnLst>
-                                    <p:set>
-                                      <p:cBhvr>
-                                        <p:cTn id="44" dur="1" fill="hold">
-                                          <p:stCondLst>
-                                            <p:cond delay="0"/>
-                                          </p:stCondLst>
-                                        </p:cTn>
-                                        <p:tgtEl>
-                                          <p:spTgt spid="3">
-                                            <p:txEl>
-                                              <p:pRg st="12" end="12"/>
-                                            </p:txEl>
-                                          </p:spTgt>
-                                        </p:tgtEl>
-                                        <p:attrNameLst>
-                                          <p:attrName>style.visibility</p:attrName>
-                                        </p:attrNameLst>
-                                      </p:cBhvr>
-                                      <p:to>
-                                        <p:strVal val="visible"/>
-                                      </p:to>
-                                    </p:set>
-                                  </p:childTnLst>
-                                </p:cTn>
-                              </p:par>
-                            </p:childTnLst>
-                          </p:cTn>
-                        </p:par>
-                      </p:childTnLst>
-                    </p:cTn>
-                  </p:par>
-                  <p:par>
-                    <p:cTn id="45" fill="hold">
-                      <p:stCondLst>
-                        <p:cond delay="indefinite"/>
-                      </p:stCondLst>
-                      <p:childTnLst>
-                        <p:par>
-                          <p:cTn id="46" fill="hold">
-                            <p:stCondLst>
-                              <p:cond delay="0"/>
-                            </p:stCondLst>
-                            <p:childTnLst>
-                              <p:par>
-                                <p:cTn id="47" presetID="1" presetClass="entr" presetSubtype="0" fill="hold" grpId="0" nodeType="clickEffect">
-                                  <p:stCondLst>
-                                    <p:cond delay="0"/>
-                                  </p:stCondLst>
-                                  <p:childTnLst>
-                                    <p:set>
-                                      <p:cBhvr>
-                                        <p:cTn id="48" dur="1" fill="hold">
-                                          <p:stCondLst>
-                                            <p:cond delay="0"/>
-                                          </p:stCondLst>
-                                        </p:cTn>
-                                        <p:tgtEl>
-                                          <p:spTgt spid="3">
-                                            <p:txEl>
-                                              <p:pRg st="13" end="13"/>
-                                            </p:txEl>
-                                          </p:spTgt>
-                                        </p:tgtEl>
-                                        <p:attrNameLst>
-                                          <p:attrName>style.visibility</p:attrName>
-                                        </p:attrNameLst>
-                                      </p:cBhvr>
-                                      <p:to>
-                                        <p:strVal val="visible"/>
-                                      </p:to>
-                                    </p:set>
-                                  </p:childTnLst>
-                                </p:cTn>
-                              </p:par>
-                            </p:childTnLst>
-                          </p:cTn>
-                        </p:par>
-                      </p:childTnLst>
-                    </p:cTn>
-                  </p:par>
-                  <p:par>
-                    <p:cTn id="49" fill="hold">
-                      <p:stCondLst>
-                        <p:cond delay="indefinite"/>
-                      </p:stCondLst>
-                      <p:childTnLst>
-                        <p:par>
-                          <p:cTn id="50" fill="hold">
-                            <p:stCondLst>
-                              <p:cond delay="0"/>
-                            </p:stCondLst>
-                            <p:childTnLst>
-                              <p:par>
-                                <p:cTn id="51" presetID="1" presetClass="entr" presetSubtype="0" fill="hold" grpId="0" nodeType="clickEffect">
-                                  <p:stCondLst>
-                                    <p:cond delay="0"/>
-                                  </p:stCondLst>
-                                  <p:childTnLst>
-                                    <p:set>
-                                      <p:cBhvr>
-                                        <p:cTn id="52" dur="1" fill="hold">
-                                          <p:stCondLst>
-                                            <p:cond delay="0"/>
-                                          </p:stCondLst>
-                                        </p:cTn>
-                                        <p:tgtEl>
-                                          <p:spTgt spid="9"/>
-                                        </p:tgtEl>
-                                        <p:attrNameLst>
-                                          <p:attrName>style.visibility</p:attrName>
-                                        </p:attrNameLst>
-                                      </p:cBhvr>
-                                      <p:to>
-                                        <p:strVal val="visible"/>
-                                      </p:to>
-                                    </p:set>
-                                  </p:childTnLst>
-                                </p:cTn>
-                              </p:par>
-                            </p:childTnLst>
-                          </p:cTn>
-                        </p:par>
-                      </p:childTnLst>
-                    </p:cTn>
-                  </p:par>
-                  <p:par>
-                    <p:cTn id="53" fill="hold">
-                      <p:stCondLst>
-                        <p:cond delay="indefinite"/>
-                      </p:stCondLst>
-                      <p:childTnLst>
-                        <p:par>
-                          <p:cTn id="54" fill="hold">
-                            <p:stCondLst>
-                              <p:cond delay="0"/>
-                            </p:stCondLst>
-                            <p:childTnLst>
-                              <p:par>
-                                <p:cTn id="55" presetID="1" presetClass="entr" presetSubtype="0" fill="hold" grpId="0" nodeType="clickEffect">
-                                  <p:stCondLst>
-                                    <p:cond delay="0"/>
-                                  </p:stCondLst>
-                                  <p:childTnLst>
-                                    <p:set>
-                                      <p:cBhvr>
-                                        <p:cTn id="56" dur="1" fill="hold">
-                                          <p:stCondLst>
-                                            <p:cond delay="0"/>
-                                          </p:stCondLst>
-                                        </p:cTn>
-                                        <p:tgtEl>
-                                          <p:spTgt spid="8"/>
-                                        </p:tgtEl>
-                                        <p:attrNameLst>
-                                          <p:attrName>style.visibility</p:attrName>
-                                        </p:attrNameLst>
-                                      </p:cBhvr>
-                                      <p:to>
-                                        <p:strVal val="visible"/>
-                                      </p:to>
-                                    </p:set>
-                                  </p:childTnLst>
-                                </p:cTn>
-                              </p:par>
-                            </p:childTnLst>
-                          </p:cTn>
-                        </p:par>
-                      </p:childTnLst>
-                    </p:cTn>
-                  </p:par>
-                  <p:par>
-                    <p:cTn id="57" fill="hold">
-                      <p:stCondLst>
-                        <p:cond delay="indefinite"/>
-                      </p:stCondLst>
-                      <p:childTnLst>
-                        <p:par>
-                          <p:cTn id="58" fill="hold">
-                            <p:stCondLst>
-                              <p:cond delay="0"/>
-                            </p:stCondLst>
-                            <p:childTnLst>
-                              <p:par>
-                                <p:cTn id="59" presetID="1" presetClass="entr" presetSubtype="0" fill="hold" nodeType="clickEffect">
-                                  <p:stCondLst>
-                                    <p:cond delay="0"/>
-                                  </p:stCondLst>
-                                  <p:childTnLst>
-                                    <p:set>
-                                      <p:cBhvr>
-                                        <p:cTn id="60" dur="1" fill="hold">
+                                        <p:cTn id="26" dur="1" fill="hold">
                                           <p:stCondLst>
                                             <p:cond delay="0"/>
                                           </p:stCondLst>
@@ -14076,8 +13831,6 @@
     </p:tnLst>
     <p:bldLst>
       <p:bldP spid="3" grpId="0" uiExpand="1" build="p" bldLvl="2"/>
-      <p:bldP spid="8" grpId="0" animBg="1"/>
-      <p:bldP spid="9" grpId="0" animBg="1"/>
     </p:bldLst>
   </p:timing>
 </p:sld>

</xml_diff>